<commit_message>
Reformat paper for IEEE TCST submission and add missing figures/materials
Convert informe.tex to IEEEtran journal class, fix fabricated citations
(replaced with verified antenna-control literature), tighten abstract to
TCST length/format requirements, and add materials roadmap figures.

Co-Authored-By: Claude Sonnet 5 <noreply@anthropic.com>
</commit_message>
<xml_diff>
--- a/presentacion/presentacion.pptx
+++ b/presentacion/presentacion.pptx
@@ -16,6 +16,9 @@
     <p:sldId id="264" r:id="rId15"/>
     <p:sldId id="265" r:id="rId16"/>
     <p:sldId id="266" r:id="rId17"/>
+    <p:sldId id="267" r:id="rId18"/>
+    <p:sldId id="268" r:id="rId19"/>
+    <p:sldId id="269" r:id="rId20"/>
   </p:sldIdLst>
   <p:sldSz cx="12191695" cy="6858000" type="screen4x3"/>
   <p:notesSz cx="6858000" cy="9144000"/>
@@ -3558,6 +3561,510 @@
                 </a:solidFill>
                 <a:latin typeface="Calibri"/>
               </a:rPr>
+              <a:t>Arquitectura del prototipo: diagrama de bloques</a:t>
+            </a:r>
+          </a:p>
+        </p:txBody>
+      </p:sp>
+      <p:pic>
+        <p:nvPicPr>
+          <p:cNvPr id="4" name="Picture 3" descr="fig9_diagrama_bloques.png"/>
+          <p:cNvPicPr>
+            <a:picLocks noChangeAspect="1"/>
+          </p:cNvPicPr>
+          <p:nvPr/>
+        </p:nvPicPr>
+        <p:blipFill>
+          <a:blip r:embed="rId2"/>
+          <a:stretch>
+            <a:fillRect/>
+          </a:stretch>
+        </p:blipFill>
+        <p:spPr>
+          <a:xfrm>
+            <a:off x="3264408" y="1371600"/>
+            <a:ext cx="5657705" cy="4754880"/>
+          </a:xfrm>
+          <a:prstGeom prst="rect">
+            <a:avLst/>
+          </a:prstGeom>
+        </p:spPr>
+      </p:pic>
+      <p:sp>
+        <p:nvSpPr>
+          <p:cNvPr id="5" name="TextBox 4"/>
+          <p:cNvSpPr txBox="1"/>
+          <p:nvPr/>
+        </p:nvSpPr>
+        <p:spPr>
+          <a:xfrm>
+            <a:off x="548640" y="6492240"/>
+            <a:ext cx="10972800" cy="320040"/>
+          </a:xfrm>
+          <a:prstGeom prst="rect">
+            <a:avLst/>
+          </a:prstGeom>
+          <a:noFill/>
+        </p:spPr>
+        <p:txBody>
+          <a:bodyPr wrap="none">
+            <a:spAutoFit/>
+          </a:bodyPr>
+          <a:lstStyle/>
+          <a:p>
+            <a:r>
+              <a:rPr sz="1000">
+                <a:solidFill>
+                  <a:srgbClr val="555555"/>
+                </a:solidFill>
+              </a:rPr>
+              <a:t>11</a:t>
+            </a:r>
+          </a:p>
+        </p:txBody>
+      </p:sp>
+    </p:spTree>
+  </p:cSld>
+  <p:clrMapOvr>
+    <a:masterClrMapping/>
+  </p:clrMapOvr>
+</p:sld>
+</file>
+
+<file path=ppt/slides/slide12.xml><?xml version="1.0" encoding="utf-8"?>
+<p:sld xmlns:a="http://schemas.openxmlformats.org/drawingml/2006/main" xmlns:p="http://schemas.openxmlformats.org/presentationml/2006/main" xmlns:r="http://schemas.openxmlformats.org/officeDocument/2006/relationships">
+  <p:cSld>
+    <p:bg>
+      <p:bgPr>
+        <a:solidFill>
+          <a:srgbClr val="FFFFFF"/>
+        </a:solidFill>
+        <a:effectLst/>
+      </p:bgPr>
+    </p:bg>
+    <p:spTree>
+      <p:nvGrpSpPr>
+        <p:cNvPr id="1" name=""/>
+        <p:cNvGrpSpPr/>
+        <p:nvPr/>
+      </p:nvGrpSpPr>
+      <p:grpSpPr/>
+      <p:sp>
+        <p:nvSpPr>
+          <p:cNvPr id="2" name="Rectangle 1"/>
+          <p:cNvSpPr/>
+          <p:nvPr/>
+        </p:nvSpPr>
+        <p:spPr>
+          <a:xfrm>
+            <a:off x="0" y="0"/>
+            <a:ext cx="164592" cy="6858000"/>
+          </a:xfrm>
+          <a:prstGeom prst="rect">
+            <a:avLst/>
+          </a:prstGeom>
+          <a:solidFill>
+            <a:srgbClr val="D62728"/>
+          </a:solidFill>
+          <a:ln>
+            <a:noFill/>
+          </a:ln>
+        </p:spPr>
+        <p:style>
+          <a:lnRef idx="1">
+            <a:schemeClr val="accent1"/>
+          </a:lnRef>
+          <a:fillRef idx="3">
+            <a:schemeClr val="accent1"/>
+          </a:fillRef>
+          <a:effectRef idx="2">
+            <a:schemeClr val="accent1"/>
+          </a:effectRef>
+          <a:fontRef idx="minor">
+            <a:schemeClr val="lt1"/>
+          </a:fontRef>
+        </p:style>
+        <p:txBody>
+          <a:bodyPr rtlCol="0" anchor="ctr"/>
+          <a:lstStyle/>
+          <a:p>
+            <a:pPr algn="ctr"/>
+          </a:p>
+        </p:txBody>
+      </p:sp>
+      <p:sp>
+        <p:nvSpPr>
+          <p:cNvPr id="3" name="TextBox 2"/>
+          <p:cNvSpPr txBox="1"/>
+          <p:nvPr/>
+        </p:nvSpPr>
+        <p:spPr>
+          <a:xfrm>
+            <a:off x="548640" y="365760"/>
+            <a:ext cx="11064240" cy="914400"/>
+          </a:xfrm>
+          <a:prstGeom prst="rect">
+            <a:avLst/>
+          </a:prstGeom>
+          <a:noFill/>
+        </p:spPr>
+        <p:txBody>
+          <a:bodyPr wrap="square">
+            <a:spAutoFit/>
+          </a:bodyPr>
+          <a:lstStyle/>
+          <a:p>
+            <a:r>
+              <a:rPr sz="3200" b="1">
+                <a:solidFill>
+                  <a:srgbClr val="1B2A4A"/>
+                </a:solidFill>
+                <a:latin typeface="Calibri"/>
+              </a:rPr>
+              <a:t>Diseño mecánico y esquema eléctrico</a:t>
+            </a:r>
+          </a:p>
+        </p:txBody>
+      </p:sp>
+      <p:pic>
+        <p:nvPicPr>
+          <p:cNvPr id="4" name="Picture 3" descr="fig11_layout_mecanico.png"/>
+          <p:cNvPicPr>
+            <a:picLocks noChangeAspect="1"/>
+          </p:cNvPicPr>
+          <p:nvPr/>
+        </p:nvPicPr>
+        <p:blipFill>
+          <a:blip r:embed="rId2"/>
+          <a:stretch>
+            <a:fillRect/>
+          </a:stretch>
+        </p:blipFill>
+        <p:spPr>
+          <a:xfrm>
+            <a:off x="548640" y="1554480"/>
+            <a:ext cx="5371541" cy="4297680"/>
+          </a:xfrm>
+          <a:prstGeom prst="rect">
+            <a:avLst/>
+          </a:prstGeom>
+        </p:spPr>
+      </p:pic>
+      <p:pic>
+        <p:nvPicPr>
+          <p:cNvPr id="5" name="Picture 4" descr="fig10_esquema_electrico.png"/>
+          <p:cNvPicPr>
+            <a:picLocks noChangeAspect="1"/>
+          </p:cNvPicPr>
+          <p:nvPr/>
+        </p:nvPicPr>
+        <p:blipFill>
+          <a:blip r:embed="rId3"/>
+          <a:stretch>
+            <a:fillRect/>
+          </a:stretch>
+        </p:blipFill>
+        <p:spPr>
+          <a:xfrm>
+            <a:off x="6126480" y="1554480"/>
+            <a:ext cx="5217348" cy="4297680"/>
+          </a:xfrm>
+          <a:prstGeom prst="rect">
+            <a:avLst/>
+          </a:prstGeom>
+        </p:spPr>
+      </p:pic>
+      <p:sp>
+        <p:nvSpPr>
+          <p:cNvPr id="6" name="TextBox 5"/>
+          <p:cNvSpPr txBox="1"/>
+          <p:nvPr/>
+        </p:nvSpPr>
+        <p:spPr>
+          <a:xfrm>
+            <a:off x="548640" y="6492240"/>
+            <a:ext cx="10972800" cy="320040"/>
+          </a:xfrm>
+          <a:prstGeom prst="rect">
+            <a:avLst/>
+          </a:prstGeom>
+          <a:noFill/>
+        </p:spPr>
+        <p:txBody>
+          <a:bodyPr wrap="none">
+            <a:spAutoFit/>
+          </a:bodyPr>
+          <a:lstStyle/>
+          <a:p>
+            <a:r>
+              <a:rPr sz="1000">
+                <a:solidFill>
+                  <a:srgbClr val="555555"/>
+                </a:solidFill>
+              </a:rPr>
+              <a:t>12</a:t>
+            </a:r>
+          </a:p>
+        </p:txBody>
+      </p:sp>
+    </p:spTree>
+  </p:cSld>
+  <p:clrMapOvr>
+    <a:masterClrMapping/>
+  </p:clrMapOvr>
+</p:sld>
+</file>
+
+<file path=ppt/slides/slide13.xml><?xml version="1.0" encoding="utf-8"?>
+<p:sld xmlns:a="http://schemas.openxmlformats.org/drawingml/2006/main" xmlns:p="http://schemas.openxmlformats.org/presentationml/2006/main" xmlns:r="http://schemas.openxmlformats.org/officeDocument/2006/relationships">
+  <p:cSld>
+    <p:bg>
+      <p:bgPr>
+        <a:solidFill>
+          <a:srgbClr val="FFFFFF"/>
+        </a:solidFill>
+        <a:effectLst/>
+      </p:bgPr>
+    </p:bg>
+    <p:spTree>
+      <p:nvGrpSpPr>
+        <p:cNvPr id="1" name=""/>
+        <p:cNvGrpSpPr/>
+        <p:nvPr/>
+      </p:nvGrpSpPr>
+      <p:grpSpPr/>
+      <p:sp>
+        <p:nvSpPr>
+          <p:cNvPr id="2" name="Rectangle 1"/>
+          <p:cNvSpPr/>
+          <p:nvPr/>
+        </p:nvSpPr>
+        <p:spPr>
+          <a:xfrm>
+            <a:off x="0" y="0"/>
+            <a:ext cx="164592" cy="6858000"/>
+          </a:xfrm>
+          <a:prstGeom prst="rect">
+            <a:avLst/>
+          </a:prstGeom>
+          <a:solidFill>
+            <a:srgbClr val="D62728"/>
+          </a:solidFill>
+          <a:ln>
+            <a:noFill/>
+          </a:ln>
+        </p:spPr>
+        <p:style>
+          <a:lnRef idx="1">
+            <a:schemeClr val="accent1"/>
+          </a:lnRef>
+          <a:fillRef idx="3">
+            <a:schemeClr val="accent1"/>
+          </a:fillRef>
+          <a:effectRef idx="2">
+            <a:schemeClr val="accent1"/>
+          </a:effectRef>
+          <a:fontRef idx="minor">
+            <a:schemeClr val="lt1"/>
+          </a:fontRef>
+        </p:style>
+        <p:txBody>
+          <a:bodyPr rtlCol="0" anchor="ctr"/>
+          <a:lstStyle/>
+          <a:p>
+            <a:pPr algn="ctr"/>
+          </a:p>
+        </p:txBody>
+      </p:sp>
+      <p:sp>
+        <p:nvSpPr>
+          <p:cNvPr id="3" name="TextBox 2"/>
+          <p:cNvSpPr txBox="1"/>
+          <p:nvPr/>
+        </p:nvSpPr>
+        <p:spPr>
+          <a:xfrm>
+            <a:off x="548640" y="365760"/>
+            <a:ext cx="11064240" cy="914400"/>
+          </a:xfrm>
+          <a:prstGeom prst="rect">
+            <a:avLst/>
+          </a:prstGeom>
+          <a:noFill/>
+        </p:spPr>
+        <p:txBody>
+          <a:bodyPr wrap="square">
+            <a:spAutoFit/>
+          </a:bodyPr>
+          <a:lstStyle/>
+          <a:p>
+            <a:r>
+              <a:rPr sz="3200" b="1">
+                <a:solidFill>
+                  <a:srgbClr val="1B2A4A"/>
+                </a:solidFill>
+                <a:latin typeface="Calibri"/>
+              </a:rPr>
+              <a:t>Banco de pruebas: perturbaciones controladas</a:t>
+            </a:r>
+          </a:p>
+        </p:txBody>
+      </p:sp>
+      <p:pic>
+        <p:nvPicPr>
+          <p:cNvPr id="4" name="Picture 3" descr="fig12_banco_pruebas.png"/>
+          <p:cNvPicPr>
+            <a:picLocks noChangeAspect="1"/>
+          </p:cNvPicPr>
+          <p:nvPr/>
+        </p:nvPicPr>
+        <p:blipFill>
+          <a:blip r:embed="rId2"/>
+          <a:stretch>
+            <a:fillRect/>
+          </a:stretch>
+        </p:blipFill>
+        <p:spPr>
+          <a:xfrm>
+            <a:off x="2368296" y="1554480"/>
+            <a:ext cx="7452624" cy="4572000"/>
+          </a:xfrm>
+          <a:prstGeom prst="rect">
+            <a:avLst/>
+          </a:prstGeom>
+        </p:spPr>
+      </p:pic>
+      <p:sp>
+        <p:nvSpPr>
+          <p:cNvPr id="5" name="TextBox 4"/>
+          <p:cNvSpPr txBox="1"/>
+          <p:nvPr/>
+        </p:nvSpPr>
+        <p:spPr>
+          <a:xfrm>
+            <a:off x="548640" y="6492240"/>
+            <a:ext cx="10972800" cy="320040"/>
+          </a:xfrm>
+          <a:prstGeom prst="rect">
+            <a:avLst/>
+          </a:prstGeom>
+          <a:noFill/>
+        </p:spPr>
+        <p:txBody>
+          <a:bodyPr wrap="none">
+            <a:spAutoFit/>
+          </a:bodyPr>
+          <a:lstStyle/>
+          <a:p>
+            <a:r>
+              <a:rPr sz="1000">
+                <a:solidFill>
+                  <a:srgbClr val="555555"/>
+                </a:solidFill>
+              </a:rPr>
+              <a:t>13</a:t>
+            </a:r>
+          </a:p>
+        </p:txBody>
+      </p:sp>
+    </p:spTree>
+  </p:cSld>
+  <p:clrMapOvr>
+    <a:masterClrMapping/>
+  </p:clrMapOvr>
+</p:sld>
+</file>
+
+<file path=ppt/slides/slide14.xml><?xml version="1.0" encoding="utf-8"?>
+<p:sld xmlns:a="http://schemas.openxmlformats.org/drawingml/2006/main" xmlns:p="http://schemas.openxmlformats.org/presentationml/2006/main" xmlns:r="http://schemas.openxmlformats.org/officeDocument/2006/relationships">
+  <p:cSld>
+    <p:bg>
+      <p:bgPr>
+        <a:solidFill>
+          <a:srgbClr val="FFFFFF"/>
+        </a:solidFill>
+        <a:effectLst/>
+      </p:bgPr>
+    </p:bg>
+    <p:spTree>
+      <p:nvGrpSpPr>
+        <p:cNvPr id="1" name=""/>
+        <p:cNvGrpSpPr/>
+        <p:nvPr/>
+      </p:nvGrpSpPr>
+      <p:grpSpPr/>
+      <p:sp>
+        <p:nvSpPr>
+          <p:cNvPr id="2" name="Rectangle 1"/>
+          <p:cNvSpPr/>
+          <p:nvPr/>
+        </p:nvSpPr>
+        <p:spPr>
+          <a:xfrm>
+            <a:off x="0" y="0"/>
+            <a:ext cx="164592" cy="6858000"/>
+          </a:xfrm>
+          <a:prstGeom prst="rect">
+            <a:avLst/>
+          </a:prstGeom>
+          <a:solidFill>
+            <a:srgbClr val="D62728"/>
+          </a:solidFill>
+          <a:ln>
+            <a:noFill/>
+          </a:ln>
+        </p:spPr>
+        <p:style>
+          <a:lnRef idx="1">
+            <a:schemeClr val="accent1"/>
+          </a:lnRef>
+          <a:fillRef idx="3">
+            <a:schemeClr val="accent1"/>
+          </a:fillRef>
+          <a:effectRef idx="2">
+            <a:schemeClr val="accent1"/>
+          </a:effectRef>
+          <a:fontRef idx="minor">
+            <a:schemeClr val="lt1"/>
+          </a:fontRef>
+        </p:style>
+        <p:txBody>
+          <a:bodyPr rtlCol="0" anchor="ctr"/>
+          <a:lstStyle/>
+          <a:p>
+            <a:pPr algn="ctr"/>
+          </a:p>
+        </p:txBody>
+      </p:sp>
+      <p:sp>
+        <p:nvSpPr>
+          <p:cNvPr id="3" name="TextBox 2"/>
+          <p:cNvSpPr txBox="1"/>
+          <p:nvPr/>
+        </p:nvSpPr>
+        <p:spPr>
+          <a:xfrm>
+            <a:off x="548640" y="365760"/>
+            <a:ext cx="11064240" cy="914400"/>
+          </a:xfrm>
+          <a:prstGeom prst="rect">
+            <a:avLst/>
+          </a:prstGeom>
+          <a:noFill/>
+        </p:spPr>
+        <p:txBody>
+          <a:bodyPr wrap="square">
+            <a:spAutoFit/>
+          </a:bodyPr>
+          <a:lstStyle/>
+          <a:p>
+            <a:r>
+              <a:rPr sz="3200" b="1">
+                <a:solidFill>
+                  <a:srgbClr val="1B2A4A"/>
+                </a:solidFill>
+                <a:latin typeface="Calibri"/>
+              </a:rPr>
               <a:t>Conclusiones</a:t>
             </a:r>
           </a:p>
@@ -3694,7 +4201,7 @@
                   <a:srgbClr val="555555"/>
                 </a:solidFill>
               </a:rPr>
-              <a:t>11</a:t>
+              <a:t>14</a:t>
             </a:r>
           </a:p>
         </p:txBody>

</xml_diff>